<commit_message>
fix: corregir numero de fallos Jest en diapositiva 13 (14 a 19) para que coincida con la diapositiva 14 y la evidencia real
</commit_message>
<xml_diff>
--- a/Documentacion/presentaciones/Presentacion_Transversal_Trato_Hecho.pptx
+++ b/Documentacion/presentaciones/Presentacion_Transversal_Trato_Hecho.pptx
@@ -13983,7 +13983,7 @@
                 <a:cs typeface="Calibri"/>
                 <a:sym typeface="Calibri"/>
               </a:rPr>
-              <a:t>Integrantes:  </a:t>
+              <a:t xml:space="preserve">Integrantes:  </a:t>
             </a:r>
             <a:r>
               <a:rPr lang="en-US" sz="1733" b="1">
@@ -14007,7 +14007,7 @@
                 <a:cs typeface="Calibri"/>
                 <a:sym typeface="Calibri"/>
               </a:rPr>
-              <a:t>· </a:t>
+              <a:t xml:space="preserve">· </a:t>
             </a:r>
             <a:r>
               <a:rPr lang="en-US" sz="1733" b="1">
@@ -14082,7 +14082,7 @@
                 <a:cs typeface="Calibri"/>
                 <a:sym typeface="Calibri"/>
               </a:rPr>
-              <a:t>Asignatura:  </a:t>
+              <a:t xml:space="preserve">Asignatura:  </a:t>
             </a:r>
             <a:r>
               <a:rPr lang="en-US" sz="1600">
@@ -14356,7 +14356,7 @@
                 <a:cs typeface="Open Sans"/>
                 <a:sym typeface="Open Sans"/>
               </a:rPr>
-              <a:t> Una VPC dividida en una subnet pública conectada a Internet y una subnet privada totalmente aislada del exterior.</a:t>
+              <a:t xml:space="preserve"> Una VPC dividida en una subnet pública conectada a Internet y una subnet privada totalmente aislada del exterior.</a:t>
             </a:r>
             <a:endParaRPr/>
           </a:p>
@@ -14392,7 +14392,7 @@
                 <a:cs typeface="Open Sans"/>
                 <a:sym typeface="Open Sans"/>
               </a:rPr>
-              <a:t> Una instancia EC2 en la zona privada que sale a Internet de forma segura a través de un NAT Gateway.</a:t>
+              <a:t xml:space="preserve"> Una instancia EC2 en la zona privada que sale a Internet de forma segura a través de un NAT Gateway.</a:t>
             </a:r>
             <a:endParaRPr/>
           </a:p>
@@ -14428,7 +14428,7 @@
                 <a:cs typeface="Open Sans"/>
                 <a:sym typeface="Open Sans"/>
               </a:rPr>
-              <a:t> Un túnel de Ngrok que expone la aplicación al exterior de forma controlada sin abrir puertos públicos.</a:t>
+              <a:t xml:space="preserve"> Un túnel de Ngrok que expone la aplicación al exterior de forma controlada sin abrir puertos públicos.</a:t>
             </a:r>
             <a:endParaRPr/>
           </a:p>
@@ -14464,7 +14464,7 @@
                 <a:cs typeface="Open Sans"/>
                 <a:sym typeface="Open Sans"/>
               </a:rPr>
-              <a:t> Un Security Group que actúa como firewall filtrando estrictamente el tráfico bajo el principio de menor privilegio.</a:t>
+              <a:t xml:space="preserve"> Un Security Group que actúa como firewall filtrando estrictamente el tráfico bajo el principio de menor privilegio.</a:t>
             </a:r>
             <a:endParaRPr/>
           </a:p>
@@ -15919,7 +15919,7 @@
                 <a:cs typeface="Calibri"/>
                 <a:sym typeface="Calibri"/>
               </a:rPr>
-              <a:t>Integridad  </a:t>
+              <a:t xml:space="preserve">Integridad  </a:t>
             </a:r>
             <a:r>
               <a:rPr lang="en-US" sz="950">
@@ -16053,7 +16053,7 @@
                 <a:cs typeface="Calibri"/>
                 <a:sym typeface="Calibri"/>
               </a:rPr>
-              <a:t>Confiabilidad  </a:t>
+              <a:t xml:space="preserve">Confiabilidad  </a:t>
             </a:r>
             <a:r>
               <a:rPr lang="en-US" sz="950">
@@ -16187,7 +16187,7 @@
                 <a:cs typeface="Calibri"/>
                 <a:sym typeface="Calibri"/>
               </a:rPr>
-              <a:t>Precisión  </a:t>
+              <a:t xml:space="preserve">Precisión  </a:t>
             </a:r>
             <a:r>
               <a:rPr lang="en-US" sz="950">
@@ -16321,7 +16321,7 @@
                 <a:cs typeface="Calibri"/>
                 <a:sym typeface="Calibri"/>
               </a:rPr>
-              <a:t>Oportunidad  </a:t>
+              <a:t xml:space="preserve">Oportunidad  </a:t>
             </a:r>
             <a:r>
               <a:rPr lang="en-US" sz="950">
@@ -16455,7 +16455,7 @@
                 <a:cs typeface="Calibri"/>
                 <a:sym typeface="Calibri"/>
               </a:rPr>
-              <a:t>Seguridad  </a:t>
+              <a:t xml:space="preserve">Seguridad  </a:t>
             </a:r>
             <a:r>
               <a:rPr lang="en-US" sz="950">
@@ -16978,7 +16978,7 @@
                 <a:cs typeface="Calibri"/>
                 <a:sym typeface="Calibri"/>
               </a:rPr>
-              <a:t>Unitarias  </a:t>
+              <a:t xml:space="preserve">Unitarias  </a:t>
             </a:r>
             <a:r>
               <a:rPr lang="en-US" sz="1400">
@@ -17101,7 +17101,7 @@
                 <a:cs typeface="Calibri"/>
                 <a:sym typeface="Calibri"/>
               </a:rPr>
-              <a:t>Integración  </a:t>
+              <a:t xml:space="preserve">Integración  </a:t>
             </a:r>
             <a:r>
               <a:rPr lang="en-US" sz="1400">
@@ -17224,7 +17224,7 @@
                 <a:cs typeface="Calibri"/>
                 <a:sym typeface="Calibri"/>
               </a:rPr>
-              <a:t>Funcionales  </a:t>
+              <a:t xml:space="preserve">Funcionales  </a:t>
             </a:r>
             <a:r>
               <a:rPr lang="en-US" sz="1400">
@@ -17625,7 +17625,7 @@
                 <a:cs typeface="Calibri"/>
                 <a:sym typeface="Calibri"/>
               </a:rPr>
-              <a:t>La primera ejecución automatizada de la suite Jest (139 pruebas) detectó 14 fallos (125 aprobadas) en distintos módulos del sistema, antes de aplicar las correcciones correspondientes.</a:t>
+              <a:t>La primera ejecución automatizada de la suite Jest (139 pruebas) detectó 19 fallos (120 aprobadas) en distintos módulos del sistema, antes de aplicar las correcciones correspondientes.</a:t>
             </a:r>
             <a:endParaRPr sz="1800">
               <a:solidFill>
@@ -17736,7 +17736,7 @@
                 <a:cs typeface="Calibri"/>
                 <a:sym typeface="Calibri"/>
               </a:rPr>
-              <a:t>Cálculo y lógica  </a:t>
+              <a:t xml:space="preserve">Cálculo y lógica  </a:t>
             </a:r>
             <a:r>
               <a:rPr lang="en-US" sz="1400">
@@ -17748,7 +17748,7 @@
                 <a:cs typeface="Calibri"/>
                 <a:sym typeface="Calibri"/>
               </a:rPr>
-              <a:t>7 fallos en pruebas unitarias de cálculo de precios y lógica del chatbot</a:t>
+              <a:t>9 fallos en pruebas unitarias de cálculo de precios y lógica del chatbot</a:t>
             </a:r>
             <a:endParaRPr sz="1533">
               <a:solidFill>
@@ -17859,7 +17859,7 @@
                 <a:cs typeface="Calibri"/>
                 <a:sym typeface="Calibri"/>
               </a:rPr>
-              <a:t>Configuración  </a:t>
+              <a:t xml:space="preserve">Configuración  </a:t>
             </a:r>
             <a:r>
               <a:rPr lang="en-US" sz="1400">
@@ -17982,7 +17982,7 @@
                 <a:cs typeface="Calibri"/>
                 <a:sym typeface="Calibri"/>
               </a:rPr>
-              <a:t>Integración y seguridad  </a:t>
+              <a:t xml:space="preserve">Integración y seguridad  </a:t>
             </a:r>
             <a:r>
               <a:rPr lang="en-US" sz="1400">
@@ -17994,7 +17994,7 @@
                 <a:cs typeface="Calibri"/>
                 <a:sym typeface="Calibri"/>
               </a:rPr>
-              <a:t>4 fallos en la comunicación con el webhook y en validaciones de seguridad</a:t>
+              <a:t>7 fallos en la comunicación con el webhook y en validaciones de seguridad</a:t>
             </a:r>
             <a:endParaRPr sz="1533">
               <a:solidFill>
@@ -18418,7 +18418,7 @@
                 <a:cs typeface="Calibri"/>
                 <a:sym typeface="Calibri"/>
               </a:rPr>
-              <a:t> </a:t>
+              <a:t xml:space="preserve"> </a:t>
             </a:r>
             <a:r>
               <a:rPr lang="en-US" dirty="0" err="1">
@@ -18668,7 +18668,7 @@
                 <a:cs typeface="Calibri"/>
                 <a:sym typeface="Calibri"/>
               </a:rPr>
-              <a:t> (antes</a:t>
+              <a:t xml:space="preserve"> (antes</a:t>
             </a:r>
             <a:endParaRPr dirty="0">
               <a:solidFill>
@@ -18708,7 +18708,7 @@
                 <a:cs typeface="Calibri"/>
                 <a:sym typeface="Calibri"/>
               </a:rPr>
-              <a:t>→ </a:t>
+              <a:t xml:space="preserve">→ </a:t>
             </a:r>
             <a:r>
               <a:rPr lang="en-US" dirty="0" err="1">
@@ -18732,7 +18732,7 @@
                 <a:cs typeface="Calibri"/>
                 <a:sym typeface="Calibri"/>
               </a:rPr>
-              <a:t> de </a:t>
+              <a:t xml:space="preserve"> de </a:t>
             </a:r>
             <a:r>
               <a:rPr lang="en-US" dirty="0" err="1">
@@ -18942,7 +18942,7 @@
                 <a:cs typeface="Calibri"/>
                 <a:sym typeface="Calibri"/>
               </a:rPr>
-              <a:t>de </a:t>
+              <a:t xml:space="preserve">de </a:t>
             </a:r>
             <a:r>
               <a:rPr lang="en-US" dirty="0" err="1">
@@ -18966,7 +18966,7 @@
                 <a:cs typeface="Calibri"/>
                 <a:sym typeface="Calibri"/>
               </a:rPr>
-              <a:t> final</a:t>
+              <a:t xml:space="preserve"> final</a:t>
             </a:r>
             <a:endParaRPr dirty="0">
               <a:solidFill>
@@ -19018,7 +19018,7 @@
                 <a:cs typeface="Calibri"/>
                 <a:sym typeface="Calibri"/>
               </a:rPr>
-              <a:t> la suite Jest</a:t>
+              <a:t xml:space="preserve"> la suite Jest</a:t>
             </a:r>
             <a:endParaRPr dirty="0">
               <a:solidFill>
@@ -19079,7 +19079,7 @@
                 <a:cs typeface="Calibri"/>
                 <a:sym typeface="Calibri"/>
               </a:rPr>
-              <a:t>La evaluación RAGAS manual sobre 40 conversaciones simuladas —incluyendo flujos </a:t>
+              <a:t xml:space="preserve">La evaluación RAGAS manual sobre 40 conversaciones simuladas —incluyendo flujos </a:t>
             </a:r>
             <a:r>
               <a:rPr lang="es-CL" sz="1600" dirty="0" err="1">
@@ -19103,7 +19103,7 @@
                 <a:cs typeface="Calibri"/>
                 <a:sym typeface="Calibri"/>
               </a:rPr>
-              <a:t> completos de cotización</a:t>
+              <a:t xml:space="preserve"> completos de cotización</a:t>
             </a:r>
           </a:p>
           <a:p>
@@ -19129,7 +19129,7 @@
                 <a:cs typeface="Calibri"/>
                 <a:sym typeface="Calibri"/>
               </a:rPr>
-              <a:t> confirmó:</a:t>
+              <a:t xml:space="preserve"> confirmó:</a:t>
             </a:r>
           </a:p>
         </p:txBody>
@@ -19224,7 +19224,7 @@
                 <a:cs typeface="Calibri"/>
                 <a:sym typeface="Calibri"/>
               </a:rPr>
-              <a:t> (Fidelidad)</a:t>
+              <a:t xml:space="preserve"> (Fidelidad)</a:t>
             </a:r>
           </a:p>
           <a:p>
@@ -19354,7 +19354,7 @@
                 <a:cs typeface="Calibri"/>
                 <a:sym typeface="Calibri"/>
               </a:rPr>
-              <a:t> </a:t>
+              <a:t xml:space="preserve"> </a:t>
             </a:r>
             <a:r>
               <a:rPr lang="es-CL" b="1" dirty="0" err="1">
@@ -19378,7 +19378,7 @@
                 <a:cs typeface="Calibri"/>
                 <a:sym typeface="Calibri"/>
               </a:rPr>
-              <a:t> (Contexto)</a:t>
+              <a:t xml:space="preserve"> (Contexto)</a:t>
             </a:r>
           </a:p>
           <a:p>
@@ -19508,7 +19508,7 @@
                 <a:cs typeface="Calibri"/>
                 <a:sym typeface="Calibri"/>
               </a:rPr>
-              <a:t> </a:t>
+              <a:t xml:space="preserve"> </a:t>
             </a:r>
             <a:r>
               <a:rPr lang="es-CL" b="1" dirty="0" err="1">
@@ -19532,7 +19532,7 @@
                 <a:cs typeface="Calibri"/>
                 <a:sym typeface="Calibri"/>
               </a:rPr>
-              <a:t> (Respuesta)</a:t>
+              <a:t xml:space="preserve"> (Respuesta)</a:t>
             </a:r>
           </a:p>
           <a:p>
@@ -22540,7 +22540,7 @@
                 <a:cs typeface="Calibri"/>
                 <a:sym typeface="Calibri"/>
               </a:rPr>
-              <a:t>Faithfulness (Fidelidad): </a:t>
+              <a:t xml:space="preserve">Faithfulness (Fidelidad): </a:t>
             </a:r>
             <a:r>
               <a:rPr lang="es-CL" sz="1200">
@@ -22564,7 +22564,7 @@
                 <a:cs typeface="Calibri"/>
                 <a:sym typeface="Calibri"/>
               </a:rPr>
-              <a:t> — Resultado: 40/40</a:t>
+              <a:t xml:space="preserve"> — Resultado: 40/40</a:t>
             </a:r>
           </a:p>
           <a:p>
@@ -22593,7 +22593,7 @@
                 <a:cs typeface="Calibri"/>
                 <a:sym typeface="Calibri"/>
               </a:rPr>
-              <a:t>Context Relevancy (Relevancia de contexto): </a:t>
+              <a:t xml:space="preserve">Context Relevancy (Relevancia de contexto): </a:t>
             </a:r>
             <a:r>
               <a:rPr lang="es-CL" sz="1200">
@@ -22617,7 +22617,7 @@
                 <a:cs typeface="Calibri"/>
                 <a:sym typeface="Calibri"/>
               </a:rPr>
-              <a:t> — Resultado: 40/40</a:t>
+              <a:t xml:space="preserve"> — Resultado: 40/40</a:t>
             </a:r>
           </a:p>
           <a:p>
@@ -22646,7 +22646,7 @@
                 <a:cs typeface="Calibri"/>
                 <a:sym typeface="Calibri"/>
               </a:rPr>
-              <a:t>Answer Relevancy (Relevancia de respuesta): </a:t>
+              <a:t xml:space="preserve">Answer Relevancy (Relevancia de respuesta): </a:t>
             </a:r>
             <a:r>
               <a:rPr lang="es-CL" sz="1200">
@@ -22670,7 +22670,7 @@
                 <a:cs typeface="Calibri"/>
                 <a:sym typeface="Calibri"/>
               </a:rPr>
-              <a:t> — Resultado: 39/40 → 40/40 (corregido)</a:t>
+              <a:t xml:space="preserve"> — Resultado: 39/40 → 40/40 (corregido)</a:t>
             </a:r>
             <a:endParaRPr sz="1200">
               <a:solidFill>
@@ -26237,7 +26237,7 @@
                 <a:cs typeface="Calibri"/>
                 <a:sym typeface="Calibri"/>
               </a:rPr>
-              <a:t>Gonzalo Carvajal  </a:t>
+              <a:t xml:space="preserve">Gonzalo Carvajal  </a:t>
             </a:r>
             <a:r>
               <a:rPr lang="en-US" sz="1333">
@@ -26312,7 +26312,7 @@
                 <a:cs typeface="Calibri"/>
                 <a:sym typeface="Calibri"/>
               </a:rPr>
-              <a:t>Cristofer San Martín  </a:t>
+              <a:t xml:space="preserve">Cristofer San Martín  </a:t>
             </a:r>
             <a:r>
               <a:rPr lang="en-US" sz="1333">
@@ -26387,7 +26387,7 @@
                 <a:cs typeface="Calibri"/>
                 <a:sym typeface="Calibri"/>
               </a:rPr>
-              <a:t>Andrés Romero  </a:t>
+              <a:t xml:space="preserve">Andrés Romero  </a:t>
             </a:r>
             <a:r>
               <a:rPr lang="en-US" sz="1333">
@@ -26897,7 +26897,7 @@
                 <a:cs typeface="Calibri"/>
                 <a:sym typeface="Calibri"/>
               </a:rPr>
-              <a:t>Capa 1 — Datos  —  </a:t>
+              <a:t xml:space="preserve">Capa 1 — Datos  —  </a:t>
             </a:r>
             <a:r>
               <a:rPr lang="en-US" sz="1466">
@@ -27028,7 +27028,7 @@
                 <a:cs typeface="Calibri"/>
                 <a:sym typeface="Calibri"/>
               </a:rPr>
-              <a:t>Capa 2 — Servicios  —  </a:t>
+              <a:t xml:space="preserve">Capa 2 — Servicios  —  </a:t>
             </a:r>
             <a:r>
               <a:rPr lang="en-US" sz="1466">
@@ -27159,7 +27159,7 @@
                 <a:cs typeface="Calibri"/>
                 <a:sym typeface="Calibri"/>
               </a:rPr>
-              <a:t>Capa 3 — Orquestación  —  </a:t>
+              <a:t xml:space="preserve">Capa 3 — Orquestación  —  </a:t>
             </a:r>
             <a:r>
               <a:rPr lang="en-US" sz="1466">
@@ -27290,7 +27290,7 @@
                 <a:cs typeface="Calibri"/>
                 <a:sym typeface="Calibri"/>
               </a:rPr>
-              <a:t>Capa 4 — Interfaz  —  </a:t>
+              <a:t xml:space="preserve">Capa 4 — Interfaz  —  </a:t>
             </a:r>
             <a:r>
               <a:rPr lang="en-US" sz="1466">
@@ -27641,7 +27641,7 @@
                 <a:cs typeface="Arial"/>
                 <a:sym typeface="Arial"/>
               </a:rPr>
-              <a:t>Interfaz de chat donde el cliente </a:t>
+              <a:t xml:space="preserve">Interfaz de chat donde el cliente </a:t>
             </a:r>
             <a:endParaRPr/>
           </a:p>
@@ -27739,7 +27739,7 @@
                 <a:cs typeface="Open Sans"/>
                 <a:sym typeface="Open Sans"/>
               </a:rPr>
-              <a:t> recibe el mensaje,</a:t>
+              <a:t xml:space="preserve"> recibe el mensaje,</a:t>
             </a:r>
             <a:endParaRPr/>
           </a:p>
@@ -27763,7 +27763,7 @@
                 <a:cs typeface="Open Sans"/>
                 <a:sym typeface="Open Sans"/>
               </a:rPr>
-              <a:t> llama al agente,</a:t>
+              <a:t xml:space="preserve"> llama al agente,</a:t>
             </a:r>
             <a:endParaRPr/>
           </a:p>
@@ -27787,7 +27787,7 @@
                 <a:cs typeface="Open Sans"/>
                 <a:sym typeface="Open Sans"/>
               </a:rPr>
-              <a:t> ejecuta las herramientas</a:t>
+              <a:t xml:space="preserve"> ejecuta las herramientas</a:t>
             </a:r>
             <a:endParaRPr/>
           </a:p>
@@ -27811,7 +27811,7 @@
                 <a:cs typeface="Open Sans"/>
                 <a:sym typeface="Open Sans"/>
               </a:rPr>
-              <a:t> y notifica</a:t>
+              <a:t xml:space="preserve"> y notifica</a:t>
             </a:r>
             <a:endParaRPr/>
           </a:p>
@@ -27861,7 +27861,7 @@
                 <a:cs typeface="Open Sans"/>
                 <a:sym typeface="Open Sans"/>
               </a:rPr>
-              <a:t>El agente conversacional — </a:t>
+              <a:t xml:space="preserve">El agente conversacional — </a:t>
             </a:r>
             <a:endParaRPr/>
           </a:p>
@@ -27909,7 +27909,7 @@
                 <a:cs typeface="Open Sans"/>
                 <a:sym typeface="Open Sans"/>
               </a:rPr>
-              <a:t> calcular, guardar, cobrar o buscar</a:t>
+              <a:t xml:space="preserve"> calcular, guardar, cobrar o buscar</a:t>
             </a:r>
             <a:endParaRPr/>
           </a:p>
@@ -27933,7 +27933,7 @@
                 <a:cs typeface="Open Sans"/>
                 <a:sym typeface="Open Sans"/>
               </a:rPr>
-              <a:t> una cotización</a:t>
+              <a:t xml:space="preserve"> una cotización</a:t>
             </a:r>
             <a:endParaRPr/>
           </a:p>
@@ -27983,7 +27983,7 @@
                 <a:cs typeface="Open Sans"/>
                 <a:sym typeface="Open Sans"/>
               </a:rPr>
-              <a:t>Base de datos (PostgreSQL) </a:t>
+              <a:t xml:space="preserve">Base de datos (PostgreSQL) </a:t>
             </a:r>
             <a:endParaRPr/>
           </a:p>
@@ -28007,7 +28007,7 @@
                 <a:cs typeface="Open Sans"/>
                 <a:sym typeface="Open Sans"/>
               </a:rPr>
-              <a:t>donde se guardan </a:t>
+              <a:t xml:space="preserve">donde se guardan </a:t>
             </a:r>
             <a:endParaRPr/>
           </a:p>
@@ -28081,7 +28081,7 @@
                 <a:cs typeface="Open Sans"/>
                 <a:sym typeface="Open Sans"/>
               </a:rPr>
-              <a:t>Genera el link de pago real </a:t>
+              <a:t xml:space="preserve">Genera el link de pago real </a:t>
             </a:r>
             <a:endParaRPr/>
           </a:p>
@@ -28179,7 +28179,7 @@
                 <a:cs typeface="Open Sans"/>
                 <a:sym typeface="Open Sans"/>
               </a:rPr>
-              <a:t> al instante cuando hay una </a:t>
+              <a:t xml:space="preserve"> al instante cuando hay una </a:t>
             </a:r>
             <a:endParaRPr/>
           </a:p>
@@ -28358,7 +28358,7 @@
                 <a:cs typeface="Open Sans"/>
                 <a:sym typeface="Open Sans"/>
               </a:rPr>
-              <a:t>Cuando se crea una nueva </a:t>
+              <a:t xml:space="preserve">Cuando se crea una nueva </a:t>
             </a:r>
             <a:endParaRPr/>
           </a:p>
@@ -28496,7 +28496,7 @@
                 <a:cs typeface="Open Sans"/>
                 <a:sym typeface="Open Sans"/>
               </a:rPr>
-              <a:t> — Punto de entrada — recibe el mensaje del cliente</a:t>
+              <a:t xml:space="preserve"> — Punto de entrada — recibe el mensaje del cliente</a:t>
             </a:r>
             <a:endParaRPr/>
           </a:p>
@@ -28532,7 +28532,7 @@
                 <a:cs typeface="Open Sans"/>
                 <a:sym typeface="Open Sans"/>
               </a:rPr>
-              <a:t> — Cerebro del sistema — decide qué hacer con cada mensaje</a:t>
+              <a:t xml:space="preserve"> — Cerebro del sistema — decide qué hacer con cada mensaje</a:t>
             </a:r>
             <a:endParaRPr/>
           </a:p>
@@ -28568,7 +28568,7 @@
                 <a:cs typeface="Open Sans"/>
                 <a:sym typeface="Open Sans"/>
               </a:rPr>
-              <a:t> — Recuerda el contexto de la conversación</a:t>
+              <a:t xml:space="preserve"> — Recuerda el contexto de la conversación</a:t>
             </a:r>
             <a:endParaRPr/>
           </a:p>
@@ -28604,7 +28604,7 @@
                 <a:cs typeface="Open Sans"/>
                 <a:sym typeface="Open Sans"/>
               </a:rPr>
-              <a:t> — calcular_precio · guardar_cotización · generar_pago · buscar_cotización</a:t>
+              <a:t xml:space="preserve"> — calcular_precio · guardar_cotización · generar_pago · buscar_cotización</a:t>
             </a:r>
             <a:endParaRPr/>
           </a:p>
@@ -28640,7 +28640,7 @@
                 <a:cs typeface="Open Sans"/>
                 <a:sym typeface="Open Sans"/>
               </a:rPr>
-              <a:t> — Filtros que activan la notificación correcta</a:t>
+              <a:t xml:space="preserve"> — Filtros que activan la notificación correcta</a:t>
             </a:r>
             <a:endParaRPr/>
           </a:p>
@@ -28676,7 +28676,7 @@
                 <a:cs typeface="Open Sans"/>
                 <a:sym typeface="Open Sans"/>
               </a:rPr>
-              <a:t> — Avisan al negocio al instante</a:t>
+              <a:t xml:space="preserve"> — Avisan al negocio al instante</a:t>
             </a:r>
             <a:endParaRPr/>
           </a:p>
@@ -29728,7 +29728,7 @@
                       </a:pPr>
                       <a:r>
                         <a:rPr lang="en-US" sz="1800" u="none" strike="noStrike" cap="none"/>
-                        <a:t>Corregido : El monto siempre sale de la base de datos </a:t>
+                        <a:t xml:space="preserve">Corregido : El monto siempre sale de la base de datos </a:t>
                       </a:r>
                       <a:endParaRPr/>
                     </a:p>
@@ -30326,7 +30326,7 @@
                       </a:pPr>
                       <a:r>
                         <a:rPr lang="en-US" sz="1800" u="none" strike="noStrike" cap="none"/>
-                        <a:t>Corregido : Activamos Row Level en las tablas </a:t>
+                        <a:t xml:space="preserve">Corregido : Activamos Row Level en las tablas </a:t>
                       </a:r>
                       <a:endParaRPr/>
                     </a:p>
@@ -30567,7 +30567,7 @@
                 <a:cs typeface="Open Sans"/>
                 <a:sym typeface="Open Sans"/>
               </a:rPr>
-              <a:t>detect-secrets </a:t>
+              <a:t xml:space="preserve">detect-secrets </a:t>
             </a:r>
             <a:endParaRPr/>
           </a:p>

</xml_diff>